<commit_message>
problem solve and manu figs
</commit_message>
<xml_diff>
--- a/figures/AllRxnNorms.pptx
+++ b/figures/AllRxnNorms.pptx
@@ -150,14 +150,6 @@
 </p:presentation>
 </file>
 
-<file path=ppt/revisionInfo.xml><?xml version="1.0" encoding="utf-8"?>
-<p1510:revInfo xmlns:a="http://schemas.openxmlformats.org/drawingml/2006/main" xmlns:r="http://schemas.openxmlformats.org/officeDocument/2006/relationships" xmlns:p1510="http://schemas.microsoft.com/office/powerpoint/2015/10/main">
-  <p1510:revLst>
-    <p1510:client id="{82869051-1B2F-4934-968A-C969E15B960C}" v="63" dt="2024-08-07T19:59:38.964"/>
-  </p1510:revLst>
-</p1510:revInfo>
-</file>
-
 <file path=ppt/changesInfos/changesInfo1.xml><?xml version="1.0" encoding="utf-8"?>
 <pc:chgInfo xmlns:a="http://schemas.openxmlformats.org/drawingml/2006/main" xmlns:r="http://schemas.openxmlformats.org/officeDocument/2006/relationships" xmlns:ac="http://schemas.microsoft.com/office/drawing/2013/main/command" xmlns:pc="http://schemas.microsoft.com/office/powerpoint/2013/main/command">
   <pc:docChgLst>
@@ -2145,6 +2137,70 @@
       </pc:sldChg>
     </pc:docChg>
   </pc:docChgLst>
+  <pc:docChgLst>
+    <pc:chgData name="Buysse, Sophie" userId="b97a91af-7430-4a7c-b7aa-bedf51cd7b1e" providerId="ADAL" clId="{73EF82B6-316D-41AA-B451-EB8CE6017397}"/>
+    <pc:docChg chg="custSel modSld">
+      <pc:chgData name="Buysse, Sophie" userId="b97a91af-7430-4a7c-b7aa-bedf51cd7b1e" providerId="ADAL" clId="{73EF82B6-316D-41AA-B451-EB8CE6017397}" dt="2024-08-15T19:30:46.698" v="13" actId="1076"/>
+      <pc:docMkLst>
+        <pc:docMk/>
+      </pc:docMkLst>
+      <pc:sldChg chg="addSp delSp modSp mod">
+        <pc:chgData name="Buysse, Sophie" userId="b97a91af-7430-4a7c-b7aa-bedf51cd7b1e" providerId="ADAL" clId="{73EF82B6-316D-41AA-B451-EB8CE6017397}" dt="2024-08-15T19:30:46.698" v="13" actId="1076"/>
+        <pc:sldMkLst>
+          <pc:docMk/>
+          <pc:sldMk cId="1542131686" sldId="262"/>
+        </pc:sldMkLst>
+        <pc:spChg chg="mod">
+          <ac:chgData name="Buysse, Sophie" userId="b97a91af-7430-4a7c-b7aa-bedf51cd7b1e" providerId="ADAL" clId="{73EF82B6-316D-41AA-B451-EB8CE6017397}" dt="2024-08-15T19:30:46.698" v="13" actId="1076"/>
+          <ac:spMkLst>
+            <pc:docMk/>
+            <pc:sldMk cId="1542131686" sldId="262"/>
+            <ac:spMk id="8" creationId="{20AC975B-C3C7-4E59-C467-A79F9E11A6ED}"/>
+          </ac:spMkLst>
+        </pc:spChg>
+        <pc:spChg chg="del mod">
+          <ac:chgData name="Buysse, Sophie" userId="b97a91af-7430-4a7c-b7aa-bedf51cd7b1e" providerId="ADAL" clId="{73EF82B6-316D-41AA-B451-EB8CE6017397}" dt="2024-08-15T19:30:10.846" v="6" actId="478"/>
+          <ac:spMkLst>
+            <pc:docMk/>
+            <pc:sldMk cId="1542131686" sldId="262"/>
+            <ac:spMk id="9" creationId="{227051E2-ED78-CB8C-F05B-99BC0A4DFCEA}"/>
+          </ac:spMkLst>
+        </pc:spChg>
+        <pc:spChg chg="mod">
+          <ac:chgData name="Buysse, Sophie" userId="b97a91af-7430-4a7c-b7aa-bedf51cd7b1e" providerId="ADAL" clId="{73EF82B6-316D-41AA-B451-EB8CE6017397}" dt="2024-08-15T19:30:24.570" v="9" actId="1076"/>
+          <ac:spMkLst>
+            <pc:docMk/>
+            <pc:sldMk cId="1542131686" sldId="262"/>
+            <ac:spMk id="10" creationId="{9F303921-7C02-FAE7-7346-E2512CF9E4C1}"/>
+          </ac:spMkLst>
+        </pc:spChg>
+        <pc:picChg chg="add mod ord">
+          <ac:chgData name="Buysse, Sophie" userId="b97a91af-7430-4a7c-b7aa-bedf51cd7b1e" providerId="ADAL" clId="{73EF82B6-316D-41AA-B451-EB8CE6017397}" dt="2024-08-15T19:30:39.627" v="12" actId="167"/>
+          <ac:picMkLst>
+            <pc:docMk/>
+            <pc:sldMk cId="1542131686" sldId="262"/>
+            <ac:picMk id="4" creationId="{385E1B27-806D-B51D-D52E-9C6F5DBB32BF}"/>
+          </ac:picMkLst>
+        </pc:picChg>
+        <pc:picChg chg="mod">
+          <ac:chgData name="Buysse, Sophie" userId="b97a91af-7430-4a7c-b7aa-bedf51cd7b1e" providerId="ADAL" clId="{73EF82B6-316D-41AA-B451-EB8CE6017397}" dt="2024-08-15T19:30:20.913" v="8" actId="1076"/>
+          <ac:picMkLst>
+            <pc:docMk/>
+            <pc:sldMk cId="1542131686" sldId="262"/>
+            <ac:picMk id="5" creationId="{D86B1000-33E9-7E7C-BB69-F2F2E2732764}"/>
+          </ac:picMkLst>
+        </pc:picChg>
+        <pc:picChg chg="del">
+          <ac:chgData name="Buysse, Sophie" userId="b97a91af-7430-4a7c-b7aa-bedf51cd7b1e" providerId="ADAL" clId="{73EF82B6-316D-41AA-B451-EB8CE6017397}" dt="2024-08-15T19:30:07.063" v="4" actId="478"/>
+          <ac:picMkLst>
+            <pc:docMk/>
+            <pc:sldMk cId="1542131686" sldId="262"/>
+            <ac:picMk id="79" creationId="{175DBA8D-929E-4088-D54F-2CCA30411F34}"/>
+          </ac:picMkLst>
+        </pc:picChg>
+      </pc:sldChg>
+    </pc:docChg>
+  </pc:docChgLst>
 </pc:chgInfo>
 </file>
 
@@ -2230,7 +2286,7 @@
           <a:p>
             <a:fld id="{050CDA19-A44C-45E3-A664-EDE6923A0E55}" type="datetimeFigureOut">
               <a:rPr lang="en-US" smtClean="0"/>
-              <a:t>8/7/2024</a:t>
+              <a:t>8/15/2024</a:t>
             </a:fld>
             <a:endParaRPr lang="en-US"/>
           </a:p>
@@ -3755,7 +3811,7 @@
           <a:p>
             <a:fld id="{DE0D81BB-EECC-4F1D-846F-A292FDFCA23D}" type="datetimeFigureOut">
               <a:rPr lang="en-US" smtClean="0"/>
-              <a:t>8/7/2024</a:t>
+              <a:t>8/15/2024</a:t>
             </a:fld>
             <a:endParaRPr lang="en-US"/>
           </a:p>
@@ -3925,7 +3981,7 @@
           <a:p>
             <a:fld id="{DE0D81BB-EECC-4F1D-846F-A292FDFCA23D}" type="datetimeFigureOut">
               <a:rPr lang="en-US" smtClean="0"/>
-              <a:t>8/7/2024</a:t>
+              <a:t>8/15/2024</a:t>
             </a:fld>
             <a:endParaRPr lang="en-US"/>
           </a:p>
@@ -4105,7 +4161,7 @@
           <a:p>
             <a:fld id="{DE0D81BB-EECC-4F1D-846F-A292FDFCA23D}" type="datetimeFigureOut">
               <a:rPr lang="en-US" smtClean="0"/>
-              <a:t>8/7/2024</a:t>
+              <a:t>8/15/2024</a:t>
             </a:fld>
             <a:endParaRPr lang="en-US"/>
           </a:p>
@@ -4275,7 +4331,7 @@
           <a:p>
             <a:fld id="{DE0D81BB-EECC-4F1D-846F-A292FDFCA23D}" type="datetimeFigureOut">
               <a:rPr lang="en-US" smtClean="0"/>
-              <a:t>8/7/2024</a:t>
+              <a:t>8/15/2024</a:t>
             </a:fld>
             <a:endParaRPr lang="en-US"/>
           </a:p>
@@ -4521,7 +4577,7 @@
           <a:p>
             <a:fld id="{DE0D81BB-EECC-4F1D-846F-A292FDFCA23D}" type="datetimeFigureOut">
               <a:rPr lang="en-US" smtClean="0"/>
-              <a:t>8/7/2024</a:t>
+              <a:t>8/15/2024</a:t>
             </a:fld>
             <a:endParaRPr lang="en-US"/>
           </a:p>
@@ -4753,7 +4809,7 @@
           <a:p>
             <a:fld id="{DE0D81BB-EECC-4F1D-846F-A292FDFCA23D}" type="datetimeFigureOut">
               <a:rPr lang="en-US" smtClean="0"/>
-              <a:t>8/7/2024</a:t>
+              <a:t>8/15/2024</a:t>
             </a:fld>
             <a:endParaRPr lang="en-US"/>
           </a:p>
@@ -5120,7 +5176,7 @@
           <a:p>
             <a:fld id="{DE0D81BB-EECC-4F1D-846F-A292FDFCA23D}" type="datetimeFigureOut">
               <a:rPr lang="en-US" smtClean="0"/>
-              <a:t>8/7/2024</a:t>
+              <a:t>8/15/2024</a:t>
             </a:fld>
             <a:endParaRPr lang="en-US"/>
           </a:p>
@@ -5238,7 +5294,7 @@
           <a:p>
             <a:fld id="{DE0D81BB-EECC-4F1D-846F-A292FDFCA23D}" type="datetimeFigureOut">
               <a:rPr lang="en-US" smtClean="0"/>
-              <a:t>8/7/2024</a:t>
+              <a:t>8/15/2024</a:t>
             </a:fld>
             <a:endParaRPr lang="en-US"/>
           </a:p>
@@ -5333,7 +5389,7 @@
           <a:p>
             <a:fld id="{DE0D81BB-EECC-4F1D-846F-A292FDFCA23D}" type="datetimeFigureOut">
               <a:rPr lang="en-US" smtClean="0"/>
-              <a:t>8/7/2024</a:t>
+              <a:t>8/15/2024</a:t>
             </a:fld>
             <a:endParaRPr lang="en-US"/>
           </a:p>
@@ -5610,7 +5666,7 @@
           <a:p>
             <a:fld id="{DE0D81BB-EECC-4F1D-846F-A292FDFCA23D}" type="datetimeFigureOut">
               <a:rPr lang="en-US" smtClean="0"/>
-              <a:t>8/7/2024</a:t>
+              <a:t>8/15/2024</a:t>
             </a:fld>
             <a:endParaRPr lang="en-US"/>
           </a:p>
@@ -5867,7 +5923,7 @@
           <a:p>
             <a:fld id="{DE0D81BB-EECC-4F1D-846F-A292FDFCA23D}" type="datetimeFigureOut">
               <a:rPr lang="en-US" smtClean="0"/>
-              <a:t>8/7/2024</a:t>
+              <a:t>8/15/2024</a:t>
             </a:fld>
             <a:endParaRPr lang="en-US"/>
           </a:p>
@@ -6080,7 +6136,7 @@
           <a:p>
             <a:fld id="{DE0D81BB-EECC-4F1D-846F-A292FDFCA23D}" type="datetimeFigureOut">
               <a:rPr lang="en-US" smtClean="0"/>
-              <a:t>8/7/2024</a:t>
+              <a:t>8/15/2024</a:t>
             </a:fld>
             <a:endParaRPr lang="en-US"/>
           </a:p>
@@ -6487,10 +6543,10 @@
       </p:grpSpPr>
       <p:pic>
         <p:nvPicPr>
-          <p:cNvPr id="5" name="Picture 4">
+          <p:cNvPr id="4" name="Picture 3">
             <a:extLst>
               <a:ext uri="{FF2B5EF4-FFF2-40B4-BE49-F238E27FC236}">
-                <a16:creationId xmlns:a16="http://schemas.microsoft.com/office/drawing/2014/main" id="{D86B1000-33E9-7E7C-BB69-F2F2E2732764}"/>
+                <a16:creationId xmlns:a16="http://schemas.microsoft.com/office/drawing/2014/main" id="{385E1B27-806D-B51D-D52E-9C6F5DBB32BF}"/>
               </a:ext>
             </a:extLst>
           </p:cNvPr>
@@ -6507,8 +6563,8 @@
         </p:blipFill>
         <p:spPr>
           <a:xfrm>
-            <a:off x="6096000" y="3276490"/>
-            <a:ext cx="4122418" cy="3657600"/>
+            <a:off x="378861" y="3174680"/>
+            <a:ext cx="6473213" cy="3820370"/>
           </a:xfrm>
           <a:prstGeom prst="rect">
             <a:avLst/>
@@ -6517,10 +6573,10 @@
       </p:pic>
       <p:pic>
         <p:nvPicPr>
-          <p:cNvPr id="79" name="Picture 78">
+          <p:cNvPr id="5" name="Picture 4">
             <a:extLst>
               <a:ext uri="{FF2B5EF4-FFF2-40B4-BE49-F238E27FC236}">
-                <a16:creationId xmlns:a16="http://schemas.microsoft.com/office/drawing/2014/main" id="{175DBA8D-929E-4088-D54F-2CCA30411F34}"/>
+                <a16:creationId xmlns:a16="http://schemas.microsoft.com/office/drawing/2014/main" id="{D86B1000-33E9-7E7C-BB69-F2F2E2732764}"/>
               </a:ext>
             </a:extLst>
           </p:cNvPr>
@@ -6537,8 +6593,8 @@
         </p:blipFill>
         <p:spPr>
           <a:xfrm>
-            <a:off x="2144008" y="3276490"/>
-            <a:ext cx="3951992" cy="3657600"/>
+            <a:off x="6852074" y="3337450"/>
+            <a:ext cx="4122418" cy="3657600"/>
           </a:xfrm>
           <a:prstGeom prst="rect">
             <a:avLst/>
@@ -6559,7 +6615,7 @@
         </p:nvSpPr>
         <p:spPr>
           <a:xfrm>
-            <a:off x="2900082" y="5166250"/>
+            <a:off x="1066048" y="5265641"/>
             <a:ext cx="834190" cy="1200329"/>
           </a:xfrm>
           <a:prstGeom prst="rect">
@@ -6594,60 +6650,6 @@
           <a:p>
             <a:r>
               <a:rPr lang="en-US" dirty="0"/>
-              <a:t>Int</a:t>
-            </a:r>
-          </a:p>
-        </p:txBody>
-      </p:sp>
-      <p:sp>
-        <p:nvSpPr>
-          <p:cNvPr id="9" name="TextBox 8">
-            <a:extLst>
-              <a:ext uri="{FF2B5EF4-FFF2-40B4-BE49-F238E27FC236}">
-                <a16:creationId xmlns:a16="http://schemas.microsoft.com/office/drawing/2014/main" id="{227051E2-ED78-CB8C-F05B-99BC0A4DFCEA}"/>
-              </a:ext>
-            </a:extLst>
-          </p:cNvPr>
-          <p:cNvSpPr txBox="1"/>
-          <p:nvPr/>
-        </p:nvSpPr>
-        <p:spPr>
-          <a:xfrm>
-            <a:off x="4961291" y="5166250"/>
-            <a:ext cx="834190" cy="1200329"/>
-          </a:xfrm>
-          <a:prstGeom prst="rect">
-            <a:avLst/>
-          </a:prstGeom>
-          <a:noFill/>
-        </p:spPr>
-        <p:txBody>
-          <a:bodyPr wrap="square" rtlCol="0">
-            <a:spAutoFit/>
-          </a:bodyPr>
-          <a:lstStyle/>
-          <a:p>
-            <a:r>
-              <a:rPr lang="en-US" dirty="0"/>
-              <a:t>2022</a:t>
-            </a:r>
-          </a:p>
-          <a:p>
-            <a:r>
-              <a:rPr lang="en-US" b="1" dirty="0"/>
-              <a:t>Pop</a:t>
-            </a:r>
-          </a:p>
-          <a:p>
-            <a:r>
-              <a:rPr lang="en-US" b="1" dirty="0" err="1"/>
-              <a:t>Trt</a:t>
-            </a:r>
-            <a:endParaRPr lang="en-US" b="1" dirty="0"/>
-          </a:p>
-          <a:p>
-            <a:r>
-              <a:rPr lang="en-US" b="1" dirty="0"/>
               <a:t>Int</a:t>
             </a:r>
           </a:p>
@@ -6667,7 +6669,7 @@
         </p:nvSpPr>
         <p:spPr>
           <a:xfrm>
-            <a:off x="6852074" y="5166250"/>
+            <a:off x="7587569" y="5166250"/>
             <a:ext cx="834190" cy="1200329"/>
           </a:xfrm>
           <a:prstGeom prst="rect">

</xml_diff>